<commit_message>
Publish M02 decks with speaker notes
Co-authored-by: shaseaver25 <shannon@tailoredu.org>
</commit_message>
<xml_diff>
--- a/teaching-pack/03-M02-measurement/M02-instructor-reveal.pptx
+++ b/teaching-pack/03-M02-measurement/M02-instructor-reveal.pptx
@@ -113,6 +113,1046 @@
     </a:lvl9pPr>
   </p:defaultTextStyle>
 </p:presentation>
+</file>
+
+<file path=ppt/notesMasters/notesMaster1.xml><?xml version="1.0" encoding="utf-8"?>
+<p:notesMaster xmlns:a="http://schemas.openxmlformats.org/drawingml/2006/main" xmlns:p="http://schemas.openxmlformats.org/presentationml/2006/main" xmlns:r="http://schemas.openxmlformats.org/officeDocument/2006/relationships">
+  <p:cSld>
+    <p:bg>
+      <p:bgRef idx="1001">
+        <a:schemeClr val="bg1"/>
+      </p:bgRef>
+    </p:bg>
+    <p:spTree>
+      <p:nvGrpSpPr>
+        <p:cNvPr id="1" name=""/>
+        <p:cNvGrpSpPr/>
+        <p:nvPr/>
+      </p:nvGrpSpPr>
+      <p:grpSpPr>
+        <a:xfrm>
+          <a:off x="0" y="0"/>
+          <a:ext cx="0" cy="0"/>
+          <a:chOff x="0" y="0"/>
+          <a:chExt cx="0" cy="0"/>
+        </a:xfrm>
+      </p:grpSpPr>
+      <p:sp>
+        <p:nvSpPr>
+          <p:cNvPr id="2" name="Header Placeholder 1"/>
+          <p:cNvSpPr>
+            <a:spLocks noGrp="1"/>
+          </p:cNvSpPr>
+          <p:nvPr>
+            <p:ph type="hdr" sz="quarter"/>
+          </p:nvPr>
+        </p:nvSpPr>
+        <p:spPr>
+          <a:xfrm>
+            <a:off x="0" y="0"/>
+            <a:ext cx="2971800" cy="457200"/>
+          </a:xfrm>
+          <a:prstGeom prst="rect">
+            <a:avLst/>
+          </a:prstGeom>
+        </p:spPr>
+        <p:txBody>
+          <a:bodyPr vert="horz" lIns="91440" tIns="45720" rIns="91440" bIns="45720" rtlCol="0"/>
+          <a:lstStyle>
+            <a:lvl1pPr algn="l">
+              <a:defRPr sz="1200"/>
+            </a:lvl1pPr>
+          </a:lstStyle>
+          <a:p>
+            <a:endParaRPr lang="en-US"/>
+          </a:p>
+        </p:txBody>
+      </p:sp>
+      <p:sp>
+        <p:nvSpPr>
+          <p:cNvPr id="3" name="Date Placeholder 2"/>
+          <p:cNvSpPr>
+            <a:spLocks noGrp="1"/>
+          </p:cNvSpPr>
+          <p:nvPr>
+            <p:ph type="dt" idx="1"/>
+          </p:nvPr>
+        </p:nvSpPr>
+        <p:spPr>
+          <a:xfrm>
+            <a:off x="3884613" y="0"/>
+            <a:ext cx="2971800" cy="457200"/>
+          </a:xfrm>
+          <a:prstGeom prst="rect">
+            <a:avLst/>
+          </a:prstGeom>
+        </p:spPr>
+        <p:txBody>
+          <a:bodyPr vert="horz" lIns="91440" tIns="45720" rIns="91440" bIns="45720" rtlCol="0"/>
+          <a:lstStyle>
+            <a:lvl1pPr algn="r">
+              <a:defRPr sz="1200"/>
+            </a:lvl1pPr>
+          </a:lstStyle>
+          <a:p>
+            <a:fld id="{0F89C1C7-3DCD-1040-A9CF-14679D8B5DDD}" type="datetimeFigureOut">
+              <a:rPr lang="en-US" smtClean="0"/>
+              <a:t>10/17/16</a:t>
+            </a:fld>
+            <a:endParaRPr lang="en-US"/>
+          </a:p>
+        </p:txBody>
+      </p:sp>
+      <p:sp>
+        <p:nvSpPr>
+          <p:cNvPr id="4" name="Slide Image Placeholder 3"/>
+          <p:cNvSpPr>
+            <a:spLocks noGrp="1" noRot="1" noChangeAspect="1"/>
+          </p:cNvSpPr>
+          <p:nvPr>
+            <p:ph type="sldImg" idx="2"/>
+          </p:nvPr>
+        </p:nvSpPr>
+        <p:spPr>
+          <a:xfrm>
+            <a:off x="1143000" y="685800"/>
+            <a:ext cx="4572000" cy="3429000"/>
+          </a:xfrm>
+          <a:prstGeom prst="rect">
+            <a:avLst/>
+          </a:prstGeom>
+          <a:noFill/>
+          <a:ln w="12700">
+            <a:solidFill>
+              <a:prstClr val="black"/>
+            </a:solidFill>
+          </a:ln>
+        </p:spPr>
+        <p:txBody>
+          <a:bodyPr vert="horz" lIns="91440" tIns="45720" rIns="91440" bIns="45720" rtlCol="0" anchor="ctr"/>
+          <a:lstStyle/>
+          <a:p>
+            <a:endParaRPr lang="en-US"/>
+          </a:p>
+        </p:txBody>
+      </p:sp>
+      <p:sp>
+        <p:nvSpPr>
+          <p:cNvPr id="5" name="Notes Placeholder 4"/>
+          <p:cNvSpPr>
+            <a:spLocks noGrp="1"/>
+          </p:cNvSpPr>
+          <p:nvPr>
+            <p:ph type="body" sz="quarter" idx="3"/>
+          </p:nvPr>
+        </p:nvSpPr>
+        <p:spPr>
+          <a:xfrm>
+            <a:off x="685800" y="4343400"/>
+            <a:ext cx="5486400" cy="4114800"/>
+          </a:xfrm>
+          <a:prstGeom prst="rect">
+            <a:avLst/>
+          </a:prstGeom>
+        </p:spPr>
+        <p:txBody>
+          <a:bodyPr vert="horz" lIns="91440" tIns="45720" rIns="91440" bIns="45720" rtlCol="0"/>
+          <a:lstStyle/>
+          <a:p>
+            <a:pPr lvl="0"/>
+            <a:r>
+              <a:rPr lang="en-US" smtClean="0"/>
+              <a:t>Click to edit Master text styles</a:t>
+            </a:r>
+          </a:p>
+          <a:p>
+            <a:pPr lvl="1"/>
+            <a:r>
+              <a:rPr lang="en-US" smtClean="0"/>
+              <a:t>Second level</a:t>
+            </a:r>
+          </a:p>
+          <a:p>
+            <a:pPr lvl="2"/>
+            <a:r>
+              <a:rPr lang="en-US" smtClean="0"/>
+              <a:t>Third level</a:t>
+            </a:r>
+          </a:p>
+          <a:p>
+            <a:pPr lvl="3"/>
+            <a:r>
+              <a:rPr lang="en-US" smtClean="0"/>
+              <a:t>Fourth level</a:t>
+            </a:r>
+          </a:p>
+          <a:p>
+            <a:pPr lvl="4"/>
+            <a:r>
+              <a:rPr lang="en-US" smtClean="0"/>
+              <a:t>Fifth level</a:t>
+            </a:r>
+            <a:endParaRPr lang="en-US"/>
+          </a:p>
+        </p:txBody>
+      </p:sp>
+      <p:sp>
+        <p:nvSpPr>
+          <p:cNvPr id="6" name="Footer Placeholder 5"/>
+          <p:cNvSpPr>
+            <a:spLocks noGrp="1"/>
+          </p:cNvSpPr>
+          <p:nvPr>
+            <p:ph type="ftr" sz="quarter" idx="4"/>
+          </p:nvPr>
+        </p:nvSpPr>
+        <p:spPr>
+          <a:xfrm>
+            <a:off x="0" y="8685213"/>
+            <a:ext cx="2971800" cy="457200"/>
+          </a:xfrm>
+          <a:prstGeom prst="rect">
+            <a:avLst/>
+          </a:prstGeom>
+        </p:spPr>
+        <p:txBody>
+          <a:bodyPr vert="horz" lIns="91440" tIns="45720" rIns="91440" bIns="45720" rtlCol="0" anchor="b"/>
+          <a:lstStyle>
+            <a:lvl1pPr algn="l">
+              <a:defRPr sz="1200"/>
+            </a:lvl1pPr>
+          </a:lstStyle>
+          <a:p>
+            <a:endParaRPr lang="en-US"/>
+          </a:p>
+        </p:txBody>
+      </p:sp>
+      <p:sp>
+        <p:nvSpPr>
+          <p:cNvPr id="7" name="Slide Number Placeholder 6"/>
+          <p:cNvSpPr>
+            <a:spLocks noGrp="1"/>
+          </p:cNvSpPr>
+          <p:nvPr>
+            <p:ph type="sldNum" sz="quarter" idx="5"/>
+          </p:nvPr>
+        </p:nvSpPr>
+        <p:spPr>
+          <a:xfrm>
+            <a:off x="3884613" y="8685213"/>
+            <a:ext cx="2971800" cy="457200"/>
+          </a:xfrm>
+          <a:prstGeom prst="rect">
+            <a:avLst/>
+          </a:prstGeom>
+        </p:spPr>
+        <p:txBody>
+          <a:bodyPr vert="horz" lIns="91440" tIns="45720" rIns="91440" bIns="45720" rtlCol="0" anchor="b"/>
+          <a:lstStyle>
+            <a:lvl1pPr algn="r">
+              <a:defRPr sz="1200"/>
+            </a:lvl1pPr>
+          </a:lstStyle>
+          <a:p>
+            <a:fld id="{BB5E49A5-4136-284D-997B-48E1D791AD67}" type="slidenum">
+              <a:rPr lang="en-US" smtClean="0"/>
+              <a:t>‹#›</a:t>
+            </a:fld>
+            <a:endParaRPr lang="en-US"/>
+          </a:p>
+        </p:txBody>
+      </p:sp>
+    </p:spTree>
+    <p:extLst>
+      <p:ext uri="{BB962C8B-B14F-4D97-AF65-F5344CB8AC3E}">
+        <p14:creationId xmlns:p14="http://schemas.microsoft.com/office/powerpoint/2010/main" val="2623252185"/>
+      </p:ext>
+    </p:extLst>
+  </p:cSld>
+  <p:clrMap bg1="lt1" tx1="dk1" bg2="lt2" tx2="dk2" accent1="accent1" accent2="accent2" accent3="accent3" accent4="accent4" accent5="accent5" accent6="accent6" hlink="hlink" folHlink="folHlink"/>
+  <p:notesStyle>
+    <a:lvl1pPr marL="0" algn="l" defTabSz="457200" rtl="0" eaLnBrk="1" latinLnBrk="0" hangingPunct="1">
+      <a:defRPr sz="1200" kern="1200">
+        <a:solidFill>
+          <a:schemeClr val="tx1"/>
+        </a:solidFill>
+        <a:latin typeface="+mn-lt"/>
+        <a:ea typeface="+mn-ea"/>
+        <a:cs typeface="+mn-cs"/>
+      </a:defRPr>
+    </a:lvl1pPr>
+    <a:lvl2pPr marL="457200" algn="l" defTabSz="457200" rtl="0" eaLnBrk="1" latinLnBrk="0" hangingPunct="1">
+      <a:defRPr sz="1200" kern="1200">
+        <a:solidFill>
+          <a:schemeClr val="tx1"/>
+        </a:solidFill>
+        <a:latin typeface="+mn-lt"/>
+        <a:ea typeface="+mn-ea"/>
+        <a:cs typeface="+mn-cs"/>
+      </a:defRPr>
+    </a:lvl2pPr>
+    <a:lvl3pPr marL="914400" algn="l" defTabSz="457200" rtl="0" eaLnBrk="1" latinLnBrk="0" hangingPunct="1">
+      <a:defRPr sz="1200" kern="1200">
+        <a:solidFill>
+          <a:schemeClr val="tx1"/>
+        </a:solidFill>
+        <a:latin typeface="+mn-lt"/>
+        <a:ea typeface="+mn-ea"/>
+        <a:cs typeface="+mn-cs"/>
+      </a:defRPr>
+    </a:lvl3pPr>
+    <a:lvl4pPr marL="1371600" algn="l" defTabSz="457200" rtl="0" eaLnBrk="1" latinLnBrk="0" hangingPunct="1">
+      <a:defRPr sz="1200" kern="1200">
+        <a:solidFill>
+          <a:schemeClr val="tx1"/>
+        </a:solidFill>
+        <a:latin typeface="+mn-lt"/>
+        <a:ea typeface="+mn-ea"/>
+        <a:cs typeface="+mn-cs"/>
+      </a:defRPr>
+    </a:lvl4pPr>
+    <a:lvl5pPr marL="1828800" algn="l" defTabSz="457200" rtl="0" eaLnBrk="1" latinLnBrk="0" hangingPunct="1">
+      <a:defRPr sz="1200" kern="1200">
+        <a:solidFill>
+          <a:schemeClr val="tx1"/>
+        </a:solidFill>
+        <a:latin typeface="+mn-lt"/>
+        <a:ea typeface="+mn-ea"/>
+        <a:cs typeface="+mn-cs"/>
+      </a:defRPr>
+    </a:lvl5pPr>
+    <a:lvl6pPr marL="2286000" algn="l" defTabSz="457200" rtl="0" eaLnBrk="1" latinLnBrk="0" hangingPunct="1">
+      <a:defRPr sz="1200" kern="1200">
+        <a:solidFill>
+          <a:schemeClr val="tx1"/>
+        </a:solidFill>
+        <a:latin typeface="+mn-lt"/>
+        <a:ea typeface="+mn-ea"/>
+        <a:cs typeface="+mn-cs"/>
+      </a:defRPr>
+    </a:lvl6pPr>
+    <a:lvl7pPr marL="2743200" algn="l" defTabSz="457200" rtl="0" eaLnBrk="1" latinLnBrk="0" hangingPunct="1">
+      <a:defRPr sz="1200" kern="1200">
+        <a:solidFill>
+          <a:schemeClr val="tx1"/>
+        </a:solidFill>
+        <a:latin typeface="+mn-lt"/>
+        <a:ea typeface="+mn-ea"/>
+        <a:cs typeface="+mn-cs"/>
+      </a:defRPr>
+    </a:lvl7pPr>
+    <a:lvl8pPr marL="3200400" algn="l" defTabSz="457200" rtl="0" eaLnBrk="1" latinLnBrk="0" hangingPunct="1">
+      <a:defRPr sz="1200" kern="1200">
+        <a:solidFill>
+          <a:schemeClr val="tx1"/>
+        </a:solidFill>
+        <a:latin typeface="+mn-lt"/>
+        <a:ea typeface="+mn-ea"/>
+        <a:cs typeface="+mn-cs"/>
+      </a:defRPr>
+    </a:lvl8pPr>
+    <a:lvl9pPr marL="3657600" algn="l" defTabSz="457200" rtl="0" eaLnBrk="1" latinLnBrk="0" hangingPunct="1">
+      <a:defRPr sz="1200" kern="1200">
+        <a:solidFill>
+          <a:schemeClr val="tx1"/>
+        </a:solidFill>
+        <a:latin typeface="+mn-lt"/>
+        <a:ea typeface="+mn-ea"/>
+        <a:cs typeface="+mn-cs"/>
+      </a:defRPr>
+    </a:lvl9pPr>
+  </p:notesStyle>
+</p:notesMaster>
+</file>
+
+<file path=ppt/notesSlides/notesSlide1.xml><?xml version="1.0" encoding="utf-8"?>
+<p:notes xmlns:a="http://schemas.openxmlformats.org/drawingml/2006/main" xmlns:p="http://schemas.openxmlformats.org/presentationml/2006/main" xmlns:r="http://schemas.openxmlformats.org/officeDocument/2006/relationships">
+  <p:cSld>
+    <p:spTree>
+      <p:nvGrpSpPr>
+        <p:cNvPr id="1" name=""/>
+        <p:cNvGrpSpPr/>
+        <p:nvPr/>
+      </p:nvGrpSpPr>
+      <p:grpSpPr>
+        <a:xfrm>
+          <a:off x="0" y="0"/>
+          <a:ext cx="0" cy="0"/>
+          <a:chOff x="0" y="0"/>
+          <a:chExt cx="0" cy="0"/>
+        </a:xfrm>
+      </p:grpSpPr>
+      <p:sp>
+        <p:nvSpPr>
+          <p:cNvPr id="2" name="Slide Image Placeholder 1"/>
+          <p:cNvSpPr>
+            <a:spLocks noGrp="1"/>
+          </p:cNvSpPr>
+          <p:nvPr>
+            <p:ph type="sldImg" idx="2"/>
+          </p:nvPr>
+        </p:nvSpPr>
+        <p:spPr/>
+      </p:sp>
+      <p:sp>
+        <p:nvSpPr>
+          <p:cNvPr id="3" name="Notes Placeholder 2"/>
+          <p:cNvSpPr>
+            <a:spLocks noGrp="1"/>
+          </p:cNvSpPr>
+          <p:nvPr>
+            <p:ph type="body" idx="3" sz="quarter"/>
+          </p:nvPr>
+        </p:nvSpPr>
+        <p:spPr/>
+        <p:txBody>
+          <a:bodyPr/>
+          <a:lstStyle/>
+          <a:p>
+            <a:r>
+              <a:t>Reader B’s consistent 33 µm height across all readings reveals a systematic error invisible within its own dataset but glaring when compared to Reader A. This highlights the importance of cross-checking instruments against external references rather than relying solely on internal consistency. Pause here to ask students: “Why might a systematic error go unnoticed within a single dataset?” Emphasize that arithmetic correctness doesn’t guarantee methodological soundness.</a:t>
+            </a:r>
+          </a:p>
+          <a:p/>
+          <a:p>
+            <a:r>
+              <a:t>[FACILITATION]: Use this moment to contrast internal validation with peer validation.</a:t>
+            </a:r>
+          </a:p>
+        </p:txBody>
+      </p:sp>
+      <p:sp>
+        <p:nvSpPr>
+          <p:cNvPr id="4" name="Slide Number Placeholder 3"/>
+          <p:cNvSpPr>
+            <a:spLocks noGrp="1"/>
+          </p:cNvSpPr>
+          <p:nvPr>
+            <p:ph type="sldNum" idx="5" sz="quarter"/>
+          </p:nvPr>
+        </p:nvSpPr>
+        <p:spPr/>
+      </p:sp>
+    </p:spTree>
+  </p:cSld>
+  <p:clrMapOvr>
+    <a:masterClrMapping/>
+  </p:clrMapOvr>
+</p:notes>
+</file>
+
+<file path=ppt/notesSlides/notesSlide2.xml><?xml version="1.0" encoding="utf-8"?>
+<p:notes xmlns:a="http://schemas.openxmlformats.org/drawingml/2006/main" xmlns:p="http://schemas.openxmlformats.org/presentationml/2006/main" xmlns:r="http://schemas.openxmlformats.org/officeDocument/2006/relationships">
+  <p:cSld>
+    <p:spTree>
+      <p:nvGrpSpPr>
+        <p:cNvPr id="1" name=""/>
+        <p:cNvGrpSpPr/>
+        <p:nvPr/>
+      </p:nvGrpSpPr>
+      <p:grpSpPr>
+        <a:xfrm>
+          <a:off x="0" y="0"/>
+          <a:ext cx="0" cy="0"/>
+          <a:chOff x="0" y="0"/>
+          <a:chExt cx="0" cy="0"/>
+        </a:xfrm>
+      </p:grpSpPr>
+      <p:sp>
+        <p:nvSpPr>
+          <p:cNvPr id="2" name="Slide Image Placeholder 1"/>
+          <p:cNvSpPr>
+            <a:spLocks noGrp="1"/>
+          </p:cNvSpPr>
+          <p:nvPr>
+            <p:ph type="sldImg" idx="2"/>
+          </p:nvPr>
+        </p:nvSpPr>
+        <p:spPr/>
+      </p:sp>
+      <p:sp>
+        <p:nvSpPr>
+          <p:cNvPr id="3" name="Notes Placeholder 2"/>
+          <p:cNvSpPr>
+            <a:spLocks noGrp="1"/>
+          </p:cNvSpPr>
+          <p:nvPr>
+            <p:ph type="body" idx="3" sz="quarter"/>
+          </p:nvPr>
+        </p:nvSpPr>
+        <p:spPr/>
+        <p:txBody>
+          <a:bodyPr/>
+          <a:lstStyle/>
+          <a:p>
+            <a:r>
+              <a:t>G6’s mean of 187.50 FAILs by ±25, while other gauges (G1–G5, G7, G8) cluster near zero and PASS. This stark contrast underscores the need to isolate outliers for deeper analysis rather than averaging them into compliance. Pause to ask: “What risks arise from averaging a single failure across multiple readings?” Note the false precision of six decimal places versus the 1 µε resolution on the install record.</a:t>
+            </a:r>
+          </a:p>
+          <a:p/>
+          <a:p>
+            <a:r>
+              <a:t>[FACILITATION]: Highlight the danger of conflating statistical noise with engineering truth.</a:t>
+            </a:r>
+          </a:p>
+        </p:txBody>
+      </p:sp>
+      <p:sp>
+        <p:nvSpPr>
+          <p:cNvPr id="4" name="Slide Number Placeholder 3"/>
+          <p:cNvSpPr>
+            <a:spLocks noGrp="1"/>
+          </p:cNvSpPr>
+          <p:nvPr>
+            <p:ph type="sldNum" idx="5" sz="quarter"/>
+          </p:nvPr>
+        </p:nvSpPr>
+        <p:spPr/>
+      </p:sp>
+    </p:spTree>
+  </p:cSld>
+  <p:clrMapOvr>
+    <a:masterClrMapping/>
+  </p:clrMapOvr>
+</p:notes>
+</file>
+
+<file path=ppt/notesSlides/notesSlide3.xml><?xml version="1.0" encoding="utf-8"?>
+<p:notes xmlns:a="http://schemas.openxmlformats.org/drawingml/2006/main" xmlns:p="http://schemas.openxmlformats.org/presentationml/2006/main" xmlns:r="http://schemas.openxmlformats.org/officeDocument/2006/relationships">
+  <p:cSld>
+    <p:spTree>
+      <p:nvGrpSpPr>
+        <p:cNvPr id="1" name=""/>
+        <p:cNvGrpSpPr/>
+        <p:nvPr/>
+      </p:nvGrpSpPr>
+      <p:grpSpPr>
+        <a:xfrm>
+          <a:off x="0" y="0"/>
+          <a:ext cx="0" cy="0"/>
+          <a:chOff x="0" y="0"/>
+          <a:chExt cx="0" cy="0"/>
+        </a:xfrm>
+      </p:grpSpPr>
+      <p:sp>
+        <p:nvSpPr>
+          <p:cNvPr id="2" name="Slide Image Placeholder 1"/>
+          <p:cNvSpPr>
+            <a:spLocks noGrp="1"/>
+          </p:cNvSpPr>
+          <p:nvPr>
+            <p:ph type="sldImg" idx="2"/>
+          </p:nvPr>
+        </p:nvSpPr>
+        <p:spPr/>
+      </p:sp>
+      <p:sp>
+        <p:nvSpPr>
+          <p:cNvPr id="3" name="Notes Placeholder 2"/>
+          <p:cNvSpPr>
+            <a:spLocks noGrp="1"/>
+          </p:cNvSpPr>
+          <p:nvPr>
+            <p:ph type="body" idx="3" sz="quarter"/>
+          </p:nvPr>
+        </p:nvSpPr>
+        <p:spPr/>
+        <p:txBody>
+          <a:bodyPr/>
+          <a:lstStyle/>
+          <a:p>
+            <a:r>
+              <a:t>G6’s tight internal spread masks its 7×-over limit mean, illustrating how a dataset can appear “correct” internally while failing externally. This reinforces the principle that consistency within a group doesn’t equate to correctness in context. Pause to ask: “How might a team overlook a critical failure if they only check internal metrics?”</a:t>
+            </a:r>
+          </a:p>
+          <a:p/>
+          <a:p>
+            <a:r>
+              <a:t>[FACILITATION]: Encourage students to question assumptions about data integrity beyond surface-level checks.</a:t>
+            </a:r>
+          </a:p>
+        </p:txBody>
+      </p:sp>
+      <p:sp>
+        <p:nvSpPr>
+          <p:cNvPr id="4" name="Slide Number Placeholder 3"/>
+          <p:cNvSpPr>
+            <a:spLocks noGrp="1"/>
+          </p:cNvSpPr>
+          <p:nvPr>
+            <p:ph type="sldNum" idx="5" sz="quarter"/>
+          </p:nvPr>
+        </p:nvSpPr>
+        <p:spPr/>
+      </p:sp>
+    </p:spTree>
+  </p:cSld>
+  <p:clrMapOvr>
+    <a:masterClrMapping/>
+  </p:clrMapOvr>
+</p:notes>
+</file>
+
+<file path=ppt/notesSlides/notesSlide4.xml><?xml version="1.0" encoding="utf-8"?>
+<p:notes xmlns:a="http://schemas.openxmlformats.org/drawingml/2006/main" xmlns:p="http://schemas.openxmlformats.org/presentationml/2006/main" xmlns:r="http://schemas.openxmlformats.org/officeDocument/2006/relationships">
+  <p:cSld>
+    <p:spTree>
+      <p:nvGrpSpPr>
+        <p:cNvPr id="1" name=""/>
+        <p:cNvGrpSpPr/>
+        <p:nvPr/>
+      </p:nvGrpSpPr>
+      <p:grpSpPr>
+        <a:xfrm>
+          <a:off x="0" y="0"/>
+          <a:ext cx="0" cy="0"/>
+          <a:chOff x="0" y="0"/>
+          <a:chExt cx="0" cy="0"/>
+        </a:xfrm>
+      </p:grpSpPr>
+      <p:sp>
+        <p:nvSpPr>
+          <p:cNvPr id="2" name="Slide Image Placeholder 1"/>
+          <p:cNvSpPr>
+            <a:spLocks noGrp="1"/>
+          </p:cNvSpPr>
+          <p:nvPr>
+            <p:ph type="sldImg" idx="2"/>
+          </p:nvPr>
+        </p:nvSpPr>
+        <p:spPr/>
+      </p:sp>
+      <p:sp>
+        <p:nvSpPr>
+          <p:cNvPr id="3" name="Notes Placeholder 2"/>
+          <p:cNvSpPr>
+            <a:spLocks noGrp="1"/>
+          </p:cNvSpPr>
+          <p:nvPr>
+            <p:ph type="body" idx="3" sz="quarter"/>
+          </p:nvPr>
+        </p:nvSpPr>
+        <p:spPr/>
+        <p:txBody>
+          <a:bodyPr/>
+          <a:lstStyle/>
+          <a:p>
+            <a:r>
+              <a:t>The PASS result arose from averaging one failure across eight gauges, diluting the error to 23.06 &lt; 25. This false compliance highlights the perils of statistical sleight-of-hand versus engineering rigor. Pause to ask: “Why is dividing a single failure by eight ethically problematic?” Note the discrepancy between six-decimal precision and the 1 µε resolution on the install record.</a:t>
+            </a:r>
+          </a:p>
+          <a:p/>
+          <a:p>
+            <a:r>
+              <a:t>[FACILITATION]: Stress that arithmetic alone cannot validate engineering decisions.</a:t>
+            </a:r>
+          </a:p>
+        </p:txBody>
+      </p:sp>
+      <p:sp>
+        <p:nvSpPr>
+          <p:cNvPr id="4" name="Slide Number Placeholder 3"/>
+          <p:cNvSpPr>
+            <a:spLocks noGrp="1"/>
+          </p:cNvSpPr>
+          <p:nvPr>
+            <p:ph type="sldNum" idx="5" sz="quarter"/>
+          </p:nvPr>
+        </p:nvSpPr>
+        <p:spPr/>
+      </p:sp>
+    </p:spTree>
+  </p:cSld>
+  <p:clrMapOvr>
+    <a:masterClrMapping/>
+  </p:clrMapOvr>
+</p:notes>
+</file>
+
+<file path=ppt/notesSlides/notesSlide5.xml><?xml version="1.0" encoding="utf-8"?>
+<p:notes xmlns:a="http://schemas.openxmlformats.org/drawingml/2006/main" xmlns:p="http://schemas.openxmlformats.org/presentationml/2006/main" xmlns:r="http://schemas.openxmlformats.org/officeDocument/2006/relationships">
+  <p:cSld>
+    <p:spTree>
+      <p:nvGrpSpPr>
+        <p:cNvPr id="1" name=""/>
+        <p:cNvGrpSpPr/>
+        <p:nvPr/>
+      </p:nvGrpSpPr>
+      <p:grpSpPr>
+        <a:xfrm>
+          <a:off x="0" y="0"/>
+          <a:ext cx="0" cy="0"/>
+          <a:chOff x="0" y="0"/>
+          <a:chExt cx="0" cy="0"/>
+        </a:xfrm>
+      </p:grpSpPr>
+      <p:sp>
+        <p:nvSpPr>
+          <p:cNvPr id="2" name="Slide Image Placeholder 1"/>
+          <p:cNvSpPr>
+            <a:spLocks noGrp="1"/>
+          </p:cNvSpPr>
+          <p:nvPr>
+            <p:ph type="sldImg" idx="2"/>
+          </p:nvPr>
+        </p:nvSpPr>
+        <p:spPr/>
+      </p:sp>
+      <p:sp>
+        <p:nvSpPr>
+          <p:cNvPr id="3" name="Notes Placeholder 2"/>
+          <p:cNvSpPr>
+            <a:spLocks noGrp="1"/>
+          </p:cNvSpPr>
+          <p:nvPr>
+            <p:ph type="body" idx="3" sz="quarter"/>
+          </p:nvPr>
+        </p:nvSpPr>
+        <p:spPr/>
+        <p:txBody>
+          <a:bodyPr/>
+          <a:lstStyle/>
+          <a:p>
+            <a:r>
+              <a:t>Wes Tanaka’s margin note says that he watched Northline re-glue G6 and did not see it re-zeroed. That is Wes’s procedural observation; it is not an estimate of anyone’s timeline.</a:t>
+            </a:r>
+          </a:p>
+          <a:p/>
+          <a:p>
+            <a:r>
+              <a:t>Keep the separate student hour-budget menu distinct: students may spend 1 hour reading the installation record, 2 hours recomputing the eight means, or 0 hours accepting the result. Do not attribute those choices to Wes. Pause to ask: “Which evidence would each student choice uncover, and what would remain unchecked?”</a:t>
+            </a:r>
+          </a:p>
+          <a:p/>
+          <a:p>
+            <a:r>
+              <a:t>[FACILITATION]: Use this to discuss the difference between field evidence and a student’s verification-budget decision.</a:t>
+            </a:r>
+          </a:p>
+        </p:txBody>
+      </p:sp>
+      <p:sp>
+        <p:nvSpPr>
+          <p:cNvPr id="4" name="Slide Number Placeholder 3"/>
+          <p:cNvSpPr>
+            <a:spLocks noGrp="1"/>
+          </p:cNvSpPr>
+          <p:nvPr>
+            <p:ph type="sldNum" idx="5" sz="quarter"/>
+          </p:nvPr>
+        </p:nvSpPr>
+        <p:spPr/>
+      </p:sp>
+    </p:spTree>
+  </p:cSld>
+  <p:clrMapOvr>
+    <a:masterClrMapping/>
+  </p:clrMapOvr>
+</p:notes>
+</file>
+
+<file path=ppt/notesSlides/notesSlide6.xml><?xml version="1.0" encoding="utf-8"?>
+<p:notes xmlns:a="http://schemas.openxmlformats.org/drawingml/2006/main" xmlns:p="http://schemas.openxmlformats.org/presentationml/2006/main" xmlns:r="http://schemas.openxmlformats.org/officeDocument/2006/relationships">
+  <p:cSld>
+    <p:spTree>
+      <p:nvGrpSpPr>
+        <p:cNvPr id="1" name=""/>
+        <p:cNvGrpSpPr/>
+        <p:nvPr/>
+      </p:nvGrpSpPr>
+      <p:grpSpPr>
+        <a:xfrm>
+          <a:off x="0" y="0"/>
+          <a:ext cx="0" cy="0"/>
+          <a:chOff x="0" y="0"/>
+          <a:chExt cx="0" cy="0"/>
+        </a:xfrm>
+      </p:grpSpPr>
+      <p:sp>
+        <p:nvSpPr>
+          <p:cNvPr id="2" name="Slide Image Placeholder 1"/>
+          <p:cNvSpPr>
+            <a:spLocks noGrp="1"/>
+          </p:cNvSpPr>
+          <p:nvPr>
+            <p:ph type="sldImg" idx="2"/>
+          </p:nvPr>
+        </p:nvSpPr>
+        <p:spPr/>
+      </p:sp>
+      <p:sp>
+        <p:nvSpPr>
+          <p:cNvPr id="3" name="Notes Placeholder 2"/>
+          <p:cNvSpPr>
+            <a:spLocks noGrp="1"/>
+          </p:cNvSpPr>
+          <p:nvPr>
+            <p:ph type="body" idx="3" sz="quarter"/>
+          </p:nvPr>
+        </p:nvSpPr>
+        <p:spPr/>
+        <p:txBody>
+          <a:bodyPr/>
+          <a:lstStyle/>
+          <a:p>
+            <a:r>
+              <a:t>The mention of a February file with students’ names foreshadows a later workflow where past data will be reused. This emphasizes the need for traceable, well-documented records to avoid future errors. Pause to ask: “Why might a February file be relevant to a later task?”</a:t>
+            </a:r>
+          </a:p>
+          <a:p/>
+          <a:p>
+            <a:r>
+              <a:t>[FACILITATION]: Encourage students to think about how their current work might impact future projects.</a:t>
+            </a:r>
+          </a:p>
+        </p:txBody>
+      </p:sp>
+      <p:sp>
+        <p:nvSpPr>
+          <p:cNvPr id="4" name="Slide Number Placeholder 3"/>
+          <p:cNvSpPr>
+            <a:spLocks noGrp="1"/>
+          </p:cNvSpPr>
+          <p:nvPr>
+            <p:ph type="sldNum" idx="5" sz="quarter"/>
+          </p:nvPr>
+        </p:nvSpPr>
+        <p:spPr/>
+      </p:sp>
+    </p:spTree>
+  </p:cSld>
+  <p:clrMapOvr>
+    <a:masterClrMapping/>
+  </p:clrMapOvr>
+</p:notes>
+</file>
+
+<file path=ppt/notesSlides/notesSlide7.xml><?xml version="1.0" encoding="utf-8"?>
+<p:notes xmlns:a="http://schemas.openxmlformats.org/drawingml/2006/main" xmlns:p="http://schemas.openxmlformats.org/presentationml/2006/main" xmlns:r="http://schemas.openxmlformats.org/officeDocument/2006/relationships">
+  <p:cSld>
+    <p:spTree>
+      <p:nvGrpSpPr>
+        <p:cNvPr id="1" name=""/>
+        <p:cNvGrpSpPr/>
+        <p:nvPr/>
+      </p:nvGrpSpPr>
+      <p:grpSpPr>
+        <a:xfrm>
+          <a:off x="0" y="0"/>
+          <a:ext cx="0" cy="0"/>
+          <a:chOff x="0" y="0"/>
+          <a:chExt cx="0" cy="0"/>
+        </a:xfrm>
+      </p:grpSpPr>
+      <p:sp>
+        <p:nvSpPr>
+          <p:cNvPr id="2" name="Slide Image Placeholder 1"/>
+          <p:cNvSpPr>
+            <a:spLocks noGrp="1"/>
+          </p:cNvSpPr>
+          <p:nvPr>
+            <p:ph type="sldImg" idx="2"/>
+          </p:nvPr>
+        </p:nvSpPr>
+        <p:spPr/>
+      </p:sp>
+      <p:sp>
+        <p:nvSpPr>
+          <p:cNvPr id="3" name="Notes Placeholder 2"/>
+          <p:cNvSpPr>
+            <a:spLocks noGrp="1"/>
+          </p:cNvSpPr>
+          <p:nvPr>
+            <p:ph type="body" idx="3" sz="quarter"/>
+          </p:nvPr>
+        </p:nvSpPr>
+        <p:spPr/>
+        <p:txBody>
+          <a:bodyPr/>
+          <a:lstStyle/>
+          <a:p>
+            <a:r>
+              <a:t>HW1 requires one page plus a decision log and hour menu, with HW1B’s lift station being a later transfer case. Clarify that this week’s focus is on immediate tasks, not future ones. Pause to ask: “What’s the difference between this week’s HW1 and the lift station in HW1B?”</a:t>
+            </a:r>
+          </a:p>
+          <a:p/>
+          <a:p>
+            <a:r>
+              <a:t>[FACILITATION]: Reinforce deadlines and scope to prevent confusion.</a:t>
+            </a:r>
+          </a:p>
+        </p:txBody>
+      </p:sp>
+      <p:sp>
+        <p:nvSpPr>
+          <p:cNvPr id="4" name="Slide Number Placeholder 3"/>
+          <p:cNvSpPr>
+            <a:spLocks noGrp="1"/>
+          </p:cNvSpPr>
+          <p:nvPr>
+            <p:ph type="sldNum" idx="5" sz="quarter"/>
+          </p:nvPr>
+        </p:nvSpPr>
+        <p:spPr/>
+      </p:sp>
+    </p:spTree>
+  </p:cSld>
+  <p:clrMapOvr>
+    <a:masterClrMapping/>
+  </p:clrMapOvr>
+</p:notes>
+</file>
+
+<file path=ppt/notesSlides/notesSlide8.xml><?xml version="1.0" encoding="utf-8"?>
+<p:notes xmlns:a="http://schemas.openxmlformats.org/drawingml/2006/main" xmlns:p="http://schemas.openxmlformats.org/presentationml/2006/main" xmlns:r="http://schemas.openxmlformats.org/officeDocument/2006/relationships">
+  <p:cSld>
+    <p:spTree>
+      <p:nvGrpSpPr>
+        <p:cNvPr id="1" name=""/>
+        <p:cNvGrpSpPr/>
+        <p:nvPr/>
+      </p:nvGrpSpPr>
+      <p:grpSpPr>
+        <a:xfrm>
+          <a:off x="0" y="0"/>
+          <a:ext cx="0" cy="0"/>
+          <a:chOff x="0" y="0"/>
+          <a:chExt cx="0" cy="0"/>
+        </a:xfrm>
+      </p:grpSpPr>
+      <p:sp>
+        <p:nvSpPr>
+          <p:cNvPr id="2" name="Slide Image Placeholder 1"/>
+          <p:cNvSpPr>
+            <a:spLocks noGrp="1"/>
+          </p:cNvSpPr>
+          <p:nvPr>
+            <p:ph type="sldImg" idx="2"/>
+          </p:nvPr>
+        </p:nvSpPr>
+        <p:spPr/>
+      </p:sp>
+      <p:sp>
+        <p:nvSpPr>
+          <p:cNvPr id="3" name="Notes Placeholder 2"/>
+          <p:cNvSpPr>
+            <a:spLocks noGrp="1"/>
+          </p:cNvSpPr>
+          <p:nvPr>
+            <p:ph type="body" idx="3" sz="quarter"/>
+          </p:nvPr>
+        </p:nvSpPr>
+        <p:spPr/>
+        <p:txBody>
+          <a:bodyPr/>
+          <a:lstStyle/>
+          <a:p>
+            <a:r>
+              <a:t>Hours are never points; nothing was hidden. Students are expected to know what they didn’t check, emphasizing accountability over blame. Pause to ask: “Why is it important to own what you didn’t verify?”</a:t>
+            </a:r>
+          </a:p>
+          <a:p/>
+          <a:p>
+            <a:r>
+              <a:t>[FACILITATION]: Use this to foster a culture of proactive responsibility.</a:t>
+            </a:r>
+          </a:p>
+        </p:txBody>
+      </p:sp>
+      <p:sp>
+        <p:nvSpPr>
+          <p:cNvPr id="4" name="Slide Number Placeholder 3"/>
+          <p:cNvSpPr>
+            <a:spLocks noGrp="1"/>
+          </p:cNvSpPr>
+          <p:nvPr>
+            <p:ph type="sldNum" idx="5" sz="quarter"/>
+          </p:nvPr>
+        </p:nvSpPr>
+        <p:spPr/>
+      </p:sp>
+    </p:spTree>
+  </p:cSld>
+  <p:clrMapOvr>
+    <a:masterClrMapping/>
+  </p:clrMapOvr>
+</p:notes>
+</file>
+
+<file path=ppt/notesSlides/notesSlide9.xml><?xml version="1.0" encoding="utf-8"?>
+<p:notes xmlns:a="http://schemas.openxmlformats.org/drawingml/2006/main" xmlns:p="http://schemas.openxmlformats.org/presentationml/2006/main" xmlns:r="http://schemas.openxmlformats.org/officeDocument/2006/relationships">
+  <p:cSld>
+    <p:spTree>
+      <p:nvGrpSpPr>
+        <p:cNvPr id="1" name=""/>
+        <p:cNvGrpSpPr/>
+        <p:nvPr/>
+      </p:nvGrpSpPr>
+      <p:grpSpPr>
+        <a:xfrm>
+          <a:off x="0" y="0"/>
+          <a:ext cx="0" cy="0"/>
+          <a:chOff x="0" y="0"/>
+          <a:chExt cx="0" cy="0"/>
+        </a:xfrm>
+      </p:grpSpPr>
+      <p:sp>
+        <p:nvSpPr>
+          <p:cNvPr id="2" name="Slide Image Placeholder 1"/>
+          <p:cNvSpPr>
+            <a:spLocks noGrp="1"/>
+          </p:cNvSpPr>
+          <p:nvPr>
+            <p:ph type="sldImg" idx="2"/>
+          </p:nvPr>
+        </p:nvSpPr>
+        <p:spPr/>
+      </p:sp>
+      <p:sp>
+        <p:nvSpPr>
+          <p:cNvPr id="3" name="Notes Placeholder 2"/>
+          <p:cNvSpPr>
+            <a:spLocks noGrp="1"/>
+          </p:cNvSpPr>
+          <p:nvPr>
+            <p:ph type="body" idx="3" sz="quarter"/>
+          </p:nvPr>
+        </p:nvSpPr>
+        <p:spPr/>
+        <p:txBody>
+          <a:bodyPr/>
+          <a:lstStyle/>
+          <a:p>
+            <a:r>
+              <a:t>Students must complete HW1 and start the decision log for week 1. On Tuesday, the FOREMAN will summarize county specs and LLM lookup risks. Pause to ask: “What should students prioritize before Tuesday’s session?”</a:t>
+            </a:r>
+          </a:p>
+          <a:p/>
+          <a:p>
+            <a:r>
+              <a:t>[FACILITATION]: Remind them to align their preparation with the instructor’s agenda.</a:t>
+            </a:r>
+          </a:p>
+        </p:txBody>
+      </p:sp>
+      <p:sp>
+        <p:nvSpPr>
+          <p:cNvPr id="4" name="Slide Number Placeholder 3"/>
+          <p:cNvSpPr>
+            <a:spLocks noGrp="1"/>
+          </p:cNvSpPr>
+          <p:nvPr>
+            <p:ph type="sldNum" idx="5" sz="quarter"/>
+          </p:nvPr>
+        </p:nvSpPr>
+        <p:spPr/>
+      </p:sp>
+    </p:spTree>
+  </p:cSld>
+  <p:clrMapOvr>
+    <a:masterClrMapping/>
+  </p:clrMapOvr>
+</p:notes>
 </file>
 
 <file path=ppt/slideLayouts/slideLayout1.xml><?xml version="1.0" encoding="utf-8"?>
@@ -7484,4 +8524,324 @@
   </a:objectDefaults>
   <a:extraClrSchemeLst/>
 </a:theme>
+</file>
+
+<file path=ppt/theme/theme2.xml><?xml version="1.0" encoding="utf-8"?>
+<a:theme xmlns:a="http://schemas.openxmlformats.org/drawingml/2006/main" name="Office Theme">
+  <a:themeElements>
+    <a:clrScheme name="Office">
+      <a:dk1>
+        <a:sysClr val="windowText" lastClr="000000"/>
+      </a:dk1>
+      <a:lt1>
+        <a:sysClr val="window" lastClr="FFFFFF"/>
+      </a:lt1>
+      <a:dk2>
+        <a:srgbClr val="1F497D"/>
+      </a:dk2>
+      <a:lt2>
+        <a:srgbClr val="EEECE1"/>
+      </a:lt2>
+      <a:accent1>
+        <a:srgbClr val="4F81BD"/>
+      </a:accent1>
+      <a:accent2>
+        <a:srgbClr val="C0504D"/>
+      </a:accent2>
+      <a:accent3>
+        <a:srgbClr val="9BBB59"/>
+      </a:accent3>
+      <a:accent4>
+        <a:srgbClr val="8064A2"/>
+      </a:accent4>
+      <a:accent5>
+        <a:srgbClr val="4BACC6"/>
+      </a:accent5>
+      <a:accent6>
+        <a:srgbClr val="F79646"/>
+      </a:accent6>
+      <a:hlink>
+        <a:srgbClr val="0000FF"/>
+      </a:hlink>
+      <a:folHlink>
+        <a:srgbClr val="800080"/>
+      </a:folHlink>
+    </a:clrScheme>
+    <a:fontScheme name="Office">
+      <a:majorFont>
+        <a:latin typeface="Calibri"/>
+        <a:ea typeface=""/>
+        <a:cs typeface=""/>
+        <a:font script="Jpan" typeface="ＭＳ Ｐゴシック"/>
+        <a:font script="Hang" typeface="맑은 고딕"/>
+        <a:font script="Hans" typeface="宋体"/>
+        <a:font script="Hant" typeface="新細明體"/>
+        <a:font script="Arab" typeface="Times New Roman"/>
+        <a:font script="Hebr" typeface="Times New Roman"/>
+        <a:font script="Thai" typeface="Angsana New"/>
+        <a:font script="Ethi" typeface="Nyala"/>
+        <a:font script="Beng" typeface="Vrinda"/>
+        <a:font script="Gujr" typeface="Shruti"/>
+        <a:font script="Khmr" typeface="MoolBoran"/>
+        <a:font script="Knda" typeface="Tunga"/>
+        <a:font script="Guru" typeface="Raavi"/>
+        <a:font script="Cans" typeface="Euphemia"/>
+        <a:font script="Cher" typeface="Plantagenet Cherokee"/>
+        <a:font script="Yiii" typeface="Microsoft Yi Baiti"/>
+        <a:font script="Tibt" typeface="Microsoft Himalaya"/>
+        <a:font script="Thaa" typeface="MV Boli"/>
+        <a:font script="Deva" typeface="Mangal"/>
+        <a:font script="Telu" typeface="Gautami"/>
+        <a:font script="Taml" typeface="Latha"/>
+        <a:font script="Syrc" typeface="Estrangelo Edessa"/>
+        <a:font script="Orya" typeface="Kalinga"/>
+        <a:font script="Mlym" typeface="Kartika"/>
+        <a:font script="Laoo" typeface="DokChampa"/>
+        <a:font script="Sinh" typeface="Iskoola Pota"/>
+        <a:font script="Mong" typeface="Mongolian Baiti"/>
+        <a:font script="Viet" typeface="Times New Roman"/>
+        <a:font script="Uigh" typeface="Microsoft Uighur"/>
+        <a:font script="Geor" typeface="Sylfaen"/>
+      </a:majorFont>
+      <a:minorFont>
+        <a:latin typeface="Calibri"/>
+        <a:ea typeface=""/>
+        <a:cs typeface=""/>
+        <a:font script="Jpan" typeface="ＭＳ Ｐゴシック"/>
+        <a:font script="Hang" typeface="맑은 고딕"/>
+        <a:font script="Hans" typeface="宋体"/>
+        <a:font script="Hant" typeface="新細明體"/>
+        <a:font script="Arab" typeface="Arial"/>
+        <a:font script="Hebr" typeface="Arial"/>
+        <a:font script="Thai" typeface="Cordia New"/>
+        <a:font script="Ethi" typeface="Nyala"/>
+        <a:font script="Beng" typeface="Vrinda"/>
+        <a:font script="Gujr" typeface="Shruti"/>
+        <a:font script="Khmr" typeface="DaunPenh"/>
+        <a:font script="Knda" typeface="Tunga"/>
+        <a:font script="Guru" typeface="Raavi"/>
+        <a:font script="Cans" typeface="Euphemia"/>
+        <a:font script="Cher" typeface="Plantagenet Cherokee"/>
+        <a:font script="Yiii" typeface="Microsoft Yi Baiti"/>
+        <a:font script="Tibt" typeface="Microsoft Himalaya"/>
+        <a:font script="Thaa" typeface="MV Boli"/>
+        <a:font script="Deva" typeface="Mangal"/>
+        <a:font script="Telu" typeface="Gautami"/>
+        <a:font script="Taml" typeface="Latha"/>
+        <a:font script="Syrc" typeface="Estrangelo Edessa"/>
+        <a:font script="Orya" typeface="Kalinga"/>
+        <a:font script="Mlym" typeface="Kartika"/>
+        <a:font script="Laoo" typeface="DokChampa"/>
+        <a:font script="Sinh" typeface="Iskoola Pota"/>
+        <a:font script="Mong" typeface="Mongolian Baiti"/>
+        <a:font script="Viet" typeface="Arial"/>
+        <a:font script="Uigh" typeface="Microsoft Uighur"/>
+        <a:font script="Geor" typeface="Sylfaen"/>
+      </a:minorFont>
+    </a:fontScheme>
+    <a:fmtScheme name="Office">
+      <a:fillStyleLst>
+        <a:solidFill>
+          <a:schemeClr val="phClr"/>
+        </a:solidFill>
+        <a:gradFill rotWithShape="1">
+          <a:gsLst>
+            <a:gs pos="0">
+              <a:schemeClr val="phClr">
+                <a:tint val="50000"/>
+                <a:satMod val="300000"/>
+              </a:schemeClr>
+            </a:gs>
+            <a:gs pos="35000">
+              <a:schemeClr val="phClr">
+                <a:tint val="37000"/>
+                <a:satMod val="300000"/>
+              </a:schemeClr>
+            </a:gs>
+            <a:gs pos="100000">
+              <a:schemeClr val="phClr">
+                <a:tint val="15000"/>
+                <a:satMod val="350000"/>
+              </a:schemeClr>
+            </a:gs>
+          </a:gsLst>
+          <a:lin ang="16200000" scaled="1"/>
+        </a:gradFill>
+        <a:gradFill rotWithShape="1">
+          <a:gsLst>
+            <a:gs pos="0">
+              <a:schemeClr val="phClr">
+                <a:tint val="100000"/>
+                <a:shade val="100000"/>
+                <a:satMod val="130000"/>
+              </a:schemeClr>
+            </a:gs>
+            <a:gs pos="100000">
+              <a:schemeClr val="phClr">
+                <a:tint val="50000"/>
+                <a:shade val="100000"/>
+                <a:satMod val="350000"/>
+              </a:schemeClr>
+            </a:gs>
+          </a:gsLst>
+          <a:lin ang="16200000" scaled="0"/>
+        </a:gradFill>
+      </a:fillStyleLst>
+      <a:lnStyleLst>
+        <a:ln w="9525" cap="flat" cmpd="sng" algn="ctr">
+          <a:solidFill>
+            <a:schemeClr val="phClr">
+              <a:shade val="95000"/>
+              <a:satMod val="105000"/>
+            </a:schemeClr>
+          </a:solidFill>
+          <a:prstDash val="solid"/>
+        </a:ln>
+        <a:ln w="25400" cap="flat" cmpd="sng" algn="ctr">
+          <a:solidFill>
+            <a:schemeClr val="phClr"/>
+          </a:solidFill>
+          <a:prstDash val="solid"/>
+        </a:ln>
+        <a:ln w="38100" cap="flat" cmpd="sng" algn="ctr">
+          <a:solidFill>
+            <a:schemeClr val="phClr"/>
+          </a:solidFill>
+          <a:prstDash val="solid"/>
+        </a:ln>
+      </a:lnStyleLst>
+      <a:effectStyleLst>
+        <a:effectStyle>
+          <a:effectLst>
+            <a:outerShdw blurRad="40000" dist="20000" dir="5400000" rotWithShape="0">
+              <a:srgbClr val="000000">
+                <a:alpha val="38000"/>
+              </a:srgbClr>
+            </a:outerShdw>
+          </a:effectLst>
+        </a:effectStyle>
+        <a:effectStyle>
+          <a:effectLst>
+            <a:outerShdw blurRad="40000" dist="23000" dir="5400000" rotWithShape="0">
+              <a:srgbClr val="000000">
+                <a:alpha val="35000"/>
+              </a:srgbClr>
+            </a:outerShdw>
+          </a:effectLst>
+        </a:effectStyle>
+        <a:effectStyle>
+          <a:effectLst>
+            <a:outerShdw blurRad="40000" dist="23000" dir="5400000" rotWithShape="0">
+              <a:srgbClr val="000000">
+                <a:alpha val="35000"/>
+              </a:srgbClr>
+            </a:outerShdw>
+          </a:effectLst>
+          <a:scene3d>
+            <a:camera prst="orthographicFront">
+              <a:rot lat="0" lon="0" rev="0"/>
+            </a:camera>
+            <a:lightRig rig="threePt" dir="t">
+              <a:rot lat="0" lon="0" rev="1200000"/>
+            </a:lightRig>
+          </a:scene3d>
+          <a:sp3d>
+            <a:bevelT w="63500" h="25400"/>
+          </a:sp3d>
+        </a:effectStyle>
+      </a:effectStyleLst>
+      <a:bgFillStyleLst>
+        <a:solidFill>
+          <a:schemeClr val="phClr"/>
+        </a:solidFill>
+        <a:gradFill rotWithShape="1">
+          <a:gsLst>
+            <a:gs pos="0">
+              <a:schemeClr val="phClr">
+                <a:tint val="40000"/>
+                <a:satMod val="350000"/>
+              </a:schemeClr>
+            </a:gs>
+            <a:gs pos="40000">
+              <a:schemeClr val="phClr">
+                <a:tint val="45000"/>
+                <a:shade val="99000"/>
+                <a:satMod val="350000"/>
+              </a:schemeClr>
+            </a:gs>
+            <a:gs pos="100000">
+              <a:schemeClr val="phClr">
+                <a:shade val="20000"/>
+                <a:satMod val="255000"/>
+              </a:schemeClr>
+            </a:gs>
+          </a:gsLst>
+          <a:path path="circle">
+            <a:fillToRect l="50000" t="-80000" r="50000" b="180000"/>
+          </a:path>
+        </a:gradFill>
+        <a:gradFill rotWithShape="1">
+          <a:gsLst>
+            <a:gs pos="0">
+              <a:schemeClr val="phClr">
+                <a:tint val="80000"/>
+                <a:satMod val="300000"/>
+              </a:schemeClr>
+            </a:gs>
+            <a:gs pos="100000">
+              <a:schemeClr val="phClr">
+                <a:shade val="30000"/>
+                <a:satMod val="200000"/>
+              </a:schemeClr>
+            </a:gs>
+          </a:gsLst>
+          <a:path path="circle">
+            <a:fillToRect l="50000" t="50000" r="50000" b="50000"/>
+          </a:path>
+        </a:gradFill>
+      </a:bgFillStyleLst>
+    </a:fmtScheme>
+  </a:themeElements>
+  <a:objectDefaults>
+    <a:spDef>
+      <a:spPr/>
+      <a:bodyPr/>
+      <a:lstStyle/>
+      <a:style>
+        <a:lnRef idx="1">
+          <a:schemeClr val="accent1"/>
+        </a:lnRef>
+        <a:fillRef idx="3">
+          <a:schemeClr val="accent1"/>
+        </a:fillRef>
+        <a:effectRef idx="2">
+          <a:schemeClr val="accent1"/>
+        </a:effectRef>
+        <a:fontRef idx="minor">
+          <a:schemeClr val="lt1"/>
+        </a:fontRef>
+      </a:style>
+    </a:spDef>
+    <a:lnDef>
+      <a:spPr/>
+      <a:bodyPr/>
+      <a:lstStyle/>
+      <a:style>
+        <a:lnRef idx="2">
+          <a:schemeClr val="accent1"/>
+        </a:lnRef>
+        <a:fillRef idx="0">
+          <a:schemeClr val="accent1"/>
+        </a:fillRef>
+        <a:effectRef idx="1">
+          <a:schemeClr val="accent1"/>
+        </a:effectRef>
+        <a:fontRef idx="minor">
+          <a:schemeClr val="tx1"/>
+        </a:fontRef>
+      </a:style>
+    </a:lnDef>
+  </a:objectDefaults>
+  <a:extraClrSchemeLst/>
+</a:theme>
 </file>
</xml_diff>